<commit_message>
Fix invoice API missing images by using PNG shapes in PPTX, update admin invoice button to open in new tab
</commit_message>
<xml_diff>
--- a/public/Modern Professional Business invoice Template - Paid.pptx
+++ b/public/Modern Professional Business invoice Template - Paid.pptx
@@ -24,10 +24,13 @@
     <p:embeddedFont>
       <p:font typeface="Open Sans" panose="020B0606030504020204" pitchFamily="34" charset="0"/>
       <p:regular r:id="rId6"/>
+      <p:bold r:id="rId7"/>
+      <p:italic r:id="rId8"/>
+      <p:boldItalic r:id="rId9"/>
     </p:embeddedFont>
     <p:embeddedFont>
       <p:font typeface="Open Sans Bold" panose="020B0806030504020204" charset="0"/>
-      <p:regular r:id="rId7"/>
+      <p:regular r:id="rId10"/>
     </p:embeddedFont>
   </p:embeddedFontLst>
   <p:defaultTextStyle>
@@ -3508,117 +3511,78 @@
           <a:chExt cx="0" cy="0"/>
         </a:xfrm>
       </p:grpSpPr>
-      <p:sp>
-        <p:nvSpPr>
-          <p:cNvPr id="2" name="Freeform 2"/>
-          <p:cNvSpPr>
-            <a:spLocks/>
-          </p:cNvSpPr>
+      <p:pic>
+        <p:nvPicPr>
+          <p:cNvPr id="26" name="Picture 25">
+            <a:extLst>
+              <a:ext uri="{FF2B5EF4-FFF2-40B4-BE49-F238E27FC236}">
+                <a16:creationId xmlns:a16="http://schemas.microsoft.com/office/drawing/2014/main" id="{3ED96D48-C8F2-98F0-05F0-599B2434AC36}"/>
+              </a:ext>
+            </a:extLst>
+          </p:cNvPr>
+          <p:cNvPicPr>
+            <a:picLocks noChangeAspect="1"/>
+          </p:cNvPicPr>
           <p:nvPr/>
-        </p:nvSpPr>
-        <p:spPr>
-          <a:xfrm>
-            <a:off x="1306830" y="10299700"/>
-            <a:ext cx="2422398" cy="600570"/>
+        </p:nvPicPr>
+        <p:blipFill>
+          <a:blip r:embed="rId3" cstate="print">
+            <a:extLst>
+              <a:ext uri="{28A0092B-C50C-407E-A947-70E740481C1C}">
+                <a14:useLocalDpi xmlns:a14="http://schemas.microsoft.com/office/drawing/2010/main" val="0"/>
+              </a:ext>
+            </a:extLst>
+          </a:blip>
+          <a:stretch>
+            <a:fillRect/>
+          </a:stretch>
+        </p:blipFill>
+        <p:spPr>
+          <a:xfrm>
+            <a:off x="1339850" y="10297242"/>
+            <a:ext cx="2421798" cy="601293"/>
           </a:xfrm>
           <a:prstGeom prst="rect">
             <a:avLst/>
           </a:prstGeom>
-          <a:blipFill>
-            <a:blip>
-              <a:extLst>
-                <a:ext uri="{96DAC541-7B7A-43D3-8B79-37D633B846F1}">
-                  <asvg:svgBlip xmlns:asvg="http://schemas.microsoft.com/office/drawing/2016/SVG/main" r:embed="rId3"/>
-                </a:ext>
-              </a:extLst>
-            </a:blip>
-            <a:stretch>
-              <a:fillRect/>
-            </a:stretch>
-          </a:blipFill>
-        </p:spPr>
-        <p:txBody>
-          <a:bodyPr/>
-          <a:lstStyle/>
-          <a:p>
-            <a:endParaRPr lang="en-US"/>
-          </a:p>
-        </p:txBody>
-      </p:sp>
-      <p:sp>
-        <p:nvSpPr>
-          <p:cNvPr id="3" name="Freeform 3"/>
-          <p:cNvSpPr>
-            <a:spLocks/>
-          </p:cNvSpPr>
+        </p:spPr>
+      </p:pic>
+      <p:pic>
+        <p:nvPicPr>
+          <p:cNvPr id="39" name="Picture 38">
+            <a:extLst>
+              <a:ext uri="{FF2B5EF4-FFF2-40B4-BE49-F238E27FC236}">
+                <a16:creationId xmlns:a16="http://schemas.microsoft.com/office/drawing/2014/main" id="{DB3D14D1-7DD2-DBBF-EF9E-16785D7F4F02}"/>
+              </a:ext>
+            </a:extLst>
+          </p:cNvPr>
+          <p:cNvPicPr>
+            <a:picLocks noChangeAspect="1"/>
+          </p:cNvPicPr>
           <p:nvPr/>
-        </p:nvSpPr>
-        <p:spPr>
-          <a:xfrm>
-            <a:off x="603228" y="10299700"/>
-            <a:ext cx="2422398" cy="600570"/>
+        </p:nvPicPr>
+        <p:blipFill>
+          <a:blip r:embed="rId4" cstate="print">
+            <a:extLst>
+              <a:ext uri="{28A0092B-C50C-407E-A947-70E740481C1C}">
+                <a14:useLocalDpi xmlns:a14="http://schemas.microsoft.com/office/drawing/2010/main" val="0"/>
+              </a:ext>
+            </a:extLst>
+          </a:blip>
+          <a:stretch>
+            <a:fillRect/>
+          </a:stretch>
+        </p:blipFill>
+        <p:spPr>
+          <a:xfrm>
+            <a:off x="598393" y="10297242"/>
+            <a:ext cx="2421798" cy="601293"/>
           </a:xfrm>
           <a:prstGeom prst="rect">
             <a:avLst/>
           </a:prstGeom>
-          <a:blipFill>
-            <a:blip>
-              <a:extLst>
-                <a:ext uri="{96DAC541-7B7A-43D3-8B79-37D633B846F1}">
-                  <asvg:svgBlip xmlns:asvg="http://schemas.microsoft.com/office/drawing/2016/SVG/main" r:embed="rId4"/>
-                </a:ext>
-              </a:extLst>
-            </a:blip>
-            <a:stretch>
-              <a:fillRect/>
-            </a:stretch>
-          </a:blipFill>
-        </p:spPr>
-        <p:txBody>
-          <a:bodyPr/>
-          <a:lstStyle/>
-          <a:p>
-            <a:endParaRPr lang="en-US"/>
-          </a:p>
-        </p:txBody>
-      </p:sp>
-      <p:sp>
-        <p:nvSpPr>
-          <p:cNvPr id="4" name="Freeform 4"/>
-          <p:cNvSpPr>
-            <a:spLocks/>
-          </p:cNvSpPr>
-          <p:nvPr/>
-        </p:nvSpPr>
-        <p:spPr>
-          <a:xfrm>
-            <a:off x="0" y="10299700"/>
-            <a:ext cx="2318642" cy="600570"/>
-          </a:xfrm>
-          <a:prstGeom prst="rect">
-            <a:avLst/>
-          </a:prstGeom>
-          <a:blipFill>
-            <a:blip>
-              <a:extLst>
-                <a:ext uri="{96DAC541-7B7A-43D3-8B79-37D633B846F1}">
-                  <asvg:svgBlip xmlns:asvg="http://schemas.microsoft.com/office/drawing/2016/SVG/main" r:embed="rId5"/>
-                </a:ext>
-              </a:extLst>
-            </a:blip>
-            <a:stretch>
-              <a:fillRect/>
-            </a:stretch>
-          </a:blipFill>
-        </p:spPr>
-        <p:txBody>
-          <a:bodyPr/>
-          <a:lstStyle/>
-          <a:p>
-            <a:endParaRPr lang="en-US"/>
-          </a:p>
-        </p:txBody>
-      </p:sp>
+        </p:spPr>
+      </p:pic>
       <p:grpSp>
         <p:nvGrpSpPr>
           <p:cNvPr id="8" name="Group 8"/>
@@ -3681,65 +3645,6 @@
           </p:txBody>
         </p:sp>
       </p:grpSp>
-      <p:sp>
-        <p:nvSpPr>
-          <p:cNvPr id="10" name="Freeform 10"/>
-          <p:cNvSpPr/>
-          <p:nvPr/>
-        </p:nvSpPr>
-        <p:spPr>
-          <a:xfrm>
-            <a:off x="1809292" y="9542764"/>
-            <a:ext cx="130959" cy="113233"/>
-          </a:xfrm>
-          <a:custGeom>
-            <a:avLst/>
-            <a:gdLst/>
-            <a:ahLst/>
-            <a:cxnLst/>
-            <a:rect l="l" t="t" r="r" b="b"/>
-            <a:pathLst>
-              <a:path w="130959" h="113233">
-                <a:moveTo>
-                  <a:pt x="0" y="0"/>
-                </a:moveTo>
-                <a:lnTo>
-                  <a:pt x="130960" y="0"/>
-                </a:lnTo>
-                <a:lnTo>
-                  <a:pt x="130960" y="113233"/>
-                </a:lnTo>
-                <a:lnTo>
-                  <a:pt x="0" y="113233"/>
-                </a:lnTo>
-                <a:lnTo>
-                  <a:pt x="0" y="0"/>
-                </a:lnTo>
-                <a:close/>
-              </a:path>
-            </a:pathLst>
-          </a:custGeom>
-          <a:blipFill>
-            <a:blip>
-              <a:extLst>
-                <a:ext uri="{96DAC541-7B7A-43D3-8B79-37D633B846F1}">
-                  <asvg:svgBlip xmlns:asvg="http://schemas.microsoft.com/office/drawing/2016/SVG/main" r:embed="rId6"/>
-                </a:ext>
-              </a:extLst>
-            </a:blip>
-            <a:stretch>
-              <a:fillRect/>
-            </a:stretch>
-          </a:blipFill>
-        </p:spPr>
-        <p:txBody>
-          <a:bodyPr/>
-          <a:lstStyle/>
-          <a:p>
-            <a:endParaRPr lang="en-US"/>
-          </a:p>
-        </p:txBody>
-      </p:sp>
       <p:grpSp>
         <p:nvGrpSpPr>
           <p:cNvPr id="11" name="Group 11"/>
@@ -3802,65 +3707,6 @@
           </p:txBody>
         </p:sp>
       </p:grpSp>
-      <p:sp>
-        <p:nvSpPr>
-          <p:cNvPr id="13" name="Freeform 13"/>
-          <p:cNvSpPr/>
-          <p:nvPr/>
-        </p:nvSpPr>
-        <p:spPr>
-          <a:xfrm>
-            <a:off x="3145311" y="9536654"/>
-            <a:ext cx="121768" cy="125454"/>
-          </a:xfrm>
-          <a:custGeom>
-            <a:avLst/>
-            <a:gdLst/>
-            <a:ahLst/>
-            <a:cxnLst/>
-            <a:rect l="l" t="t" r="r" b="b"/>
-            <a:pathLst>
-              <a:path w="121768" h="125454">
-                <a:moveTo>
-                  <a:pt x="0" y="0"/>
-                </a:moveTo>
-                <a:lnTo>
-                  <a:pt x="121767" y="0"/>
-                </a:lnTo>
-                <a:lnTo>
-                  <a:pt x="121767" y="125453"/>
-                </a:lnTo>
-                <a:lnTo>
-                  <a:pt x="0" y="125453"/>
-                </a:lnTo>
-                <a:lnTo>
-                  <a:pt x="0" y="0"/>
-                </a:lnTo>
-                <a:close/>
-              </a:path>
-            </a:pathLst>
-          </a:custGeom>
-          <a:blipFill>
-            <a:blip>
-              <a:extLst>
-                <a:ext uri="{96DAC541-7B7A-43D3-8B79-37D633B846F1}">
-                  <asvg:svgBlip xmlns:asvg="http://schemas.microsoft.com/office/drawing/2016/SVG/main" r:embed="rId7"/>
-                </a:ext>
-              </a:extLst>
-            </a:blip>
-            <a:stretch>
-              <a:fillRect/>
-            </a:stretch>
-          </a:blipFill>
-        </p:spPr>
-        <p:txBody>
-          <a:bodyPr/>
-          <a:lstStyle/>
-          <a:p>
-            <a:endParaRPr lang="en-US"/>
-          </a:p>
-        </p:txBody>
-      </p:sp>
       <p:grpSp>
         <p:nvGrpSpPr>
           <p:cNvPr id="14" name="Group 14"/>
@@ -3923,65 +3769,6 @@
           </p:txBody>
         </p:sp>
       </p:grpSp>
-      <p:sp>
-        <p:nvSpPr>
-          <p:cNvPr id="16" name="Freeform 16"/>
-          <p:cNvSpPr/>
-          <p:nvPr/>
-        </p:nvSpPr>
-        <p:spPr>
-          <a:xfrm>
-            <a:off x="4719615" y="9529529"/>
-            <a:ext cx="91716" cy="139703"/>
-          </a:xfrm>
-          <a:custGeom>
-            <a:avLst/>
-            <a:gdLst/>
-            <a:ahLst/>
-            <a:cxnLst/>
-            <a:rect l="l" t="t" r="r" b="b"/>
-            <a:pathLst>
-              <a:path w="91716" h="139703">
-                <a:moveTo>
-                  <a:pt x="0" y="0"/>
-                </a:moveTo>
-                <a:lnTo>
-                  <a:pt x="91716" y="0"/>
-                </a:lnTo>
-                <a:lnTo>
-                  <a:pt x="91716" y="139703"/>
-                </a:lnTo>
-                <a:lnTo>
-                  <a:pt x="0" y="139703"/>
-                </a:lnTo>
-                <a:lnTo>
-                  <a:pt x="0" y="0"/>
-                </a:lnTo>
-                <a:close/>
-              </a:path>
-            </a:pathLst>
-          </a:custGeom>
-          <a:blipFill>
-            <a:blip>
-              <a:extLst>
-                <a:ext uri="{96DAC541-7B7A-43D3-8B79-37D633B846F1}">
-                  <asvg:svgBlip xmlns:asvg="http://schemas.microsoft.com/office/drawing/2016/SVG/main" r:embed="rId8"/>
-                </a:ext>
-              </a:extLst>
-            </a:blip>
-            <a:stretch>
-              <a:fillRect/>
-            </a:stretch>
-          </a:blipFill>
-        </p:spPr>
-        <p:txBody>
-          <a:bodyPr/>
-          <a:lstStyle/>
-          <a:p>
-            <a:endParaRPr lang="en-US"/>
-          </a:p>
-        </p:txBody>
-      </p:sp>
       <p:grpSp>
         <p:nvGrpSpPr>
           <p:cNvPr id="17" name="Group 17"/>
@@ -4275,7 +4062,7 @@
             </a:pathLst>
           </a:custGeom>
           <a:blipFill>
-            <a:blip r:embed="rId9"/>
+            <a:blip r:embed="rId5"/>
             <a:stretch>
               <a:fillRect/>
             </a:stretch>
@@ -4298,7 +4085,7 @@
         <p:spPr>
           <a:xfrm>
             <a:off x="2038881" y="9533239"/>
-            <a:ext cx="820380" cy="115613"/>
+            <a:ext cx="820380" cy="109710"/>
           </a:xfrm>
           <a:prstGeom prst="rect">
             <a:avLst/>
@@ -4316,7 +4103,7 @@
               </a:lnSpc>
             </a:pPr>
             <a:r>
-              <a:rPr lang="en-US" sz="700" spc="11">
+              <a:rPr lang="en-US" sz="700" spc="11" dirty="0">
                 <a:solidFill>
                   <a:srgbClr val="303642"/>
                 </a:solidFill>
@@ -5095,7 +4882,7 @@
         <p:spPr>
           <a:xfrm>
             <a:off x="6088035" y="3288826"/>
-            <a:ext cx="421434" cy="156845"/>
+            <a:ext cx="731520" cy="156845"/>
           </a:xfrm>
           <a:prstGeom prst="rect">
             <a:avLst/>
@@ -5382,7 +5169,7 @@
         <p:spPr>
           <a:xfrm>
             <a:off x="755909" y="2180387"/>
-            <a:ext cx="1581519" cy="654923"/>
+            <a:ext cx="2286000" cy="654923"/>
           </a:xfrm>
           <a:prstGeom prst="rect">
             <a:avLst/>
@@ -5480,7 +5267,7 @@
         <p:spPr>
           <a:xfrm>
             <a:off x="755909" y="1887322"/>
-            <a:ext cx="2065431" cy="216149"/>
+            <a:ext cx="2926080" cy="216149"/>
           </a:xfrm>
           <a:prstGeom prst="rect">
             <a:avLst/>
@@ -6587,7 +6374,7 @@
           <p:nvPr/>
         </p:nvPicPr>
         <p:blipFill>
-          <a:blip r:embed="rId10">
+          <a:blip r:embed="rId6">
             <a:alphaModFix amt="10000"/>
             <a:extLst>
               <a:ext uri="{28A0092B-C50C-407E-A947-70E740481C1C}">
@@ -6603,6 +6390,147 @@
           <a:xfrm>
             <a:off x="4880749" y="5858825"/>
             <a:ext cx="2280190" cy="2266536"/>
+          </a:xfrm>
+          <a:prstGeom prst="rect">
+            <a:avLst/>
+          </a:prstGeom>
+        </p:spPr>
+      </p:pic>
+      <p:pic>
+        <p:nvPicPr>
+          <p:cNvPr id="24" name="Picture 23">
+            <a:extLst>
+              <a:ext uri="{FF2B5EF4-FFF2-40B4-BE49-F238E27FC236}">
+                <a16:creationId xmlns:a16="http://schemas.microsoft.com/office/drawing/2014/main" id="{41539415-234F-634D-967F-A6DCB89640FA}"/>
+              </a:ext>
+            </a:extLst>
+          </p:cNvPr>
+          <p:cNvPicPr>
+            <a:picLocks noChangeAspect="1"/>
+          </p:cNvPicPr>
+          <p:nvPr/>
+        </p:nvPicPr>
+        <p:blipFill>
+          <a:blip r:embed="rId7" cstate="print">
+            <a:extLst>
+              <a:ext uri="{28A0092B-C50C-407E-A947-70E740481C1C}">
+                <a14:useLocalDpi xmlns:a14="http://schemas.microsoft.com/office/drawing/2010/main" val="0"/>
+              </a:ext>
+            </a:extLst>
+          </a:blip>
+          <a:stretch>
+            <a:fillRect/>
+          </a:stretch>
+        </p:blipFill>
+        <p:spPr>
+          <a:xfrm>
+            <a:off x="-5176" y="10297242"/>
+            <a:ext cx="2319273" cy="601293"/>
+          </a:xfrm>
+          <a:prstGeom prst="rect">
+            <a:avLst/>
+          </a:prstGeom>
+        </p:spPr>
+      </p:pic>
+      <p:pic>
+        <p:nvPicPr>
+          <p:cNvPr id="46" name="Picture 45">
+            <a:extLst>
+              <a:ext uri="{FF2B5EF4-FFF2-40B4-BE49-F238E27FC236}">
+                <a16:creationId xmlns:a16="http://schemas.microsoft.com/office/drawing/2014/main" id="{22600E67-63ED-DB0B-3C25-1B6313980B13}"/>
+              </a:ext>
+            </a:extLst>
+          </p:cNvPr>
+          <p:cNvPicPr>
+            <a:picLocks noChangeAspect="1"/>
+          </p:cNvPicPr>
+          <p:nvPr/>
+        </p:nvPicPr>
+        <p:blipFill>
+          <a:blip r:embed="rId8" cstate="print">
+            <a:extLst>
+              <a:ext uri="{28A0092B-C50C-407E-A947-70E740481C1C}">
+                <a14:useLocalDpi xmlns:a14="http://schemas.microsoft.com/office/drawing/2010/main" val="0"/>
+              </a:ext>
+            </a:extLst>
+          </a:blip>
+          <a:srcRect/>
+          <a:stretch/>
+        </p:blipFill>
+        <p:spPr>
+          <a:xfrm flipH="1">
+            <a:off x="1824349" y="9549926"/>
+            <a:ext cx="100846" cy="100846"/>
+          </a:xfrm>
+          <a:prstGeom prst="rect">
+            <a:avLst/>
+          </a:prstGeom>
+        </p:spPr>
+      </p:pic>
+      <p:pic>
+        <p:nvPicPr>
+          <p:cNvPr id="49" name="Picture 48">
+            <a:extLst>
+              <a:ext uri="{FF2B5EF4-FFF2-40B4-BE49-F238E27FC236}">
+                <a16:creationId xmlns:a16="http://schemas.microsoft.com/office/drawing/2014/main" id="{5FF55A96-56E1-3750-28DC-CCFD62B77332}"/>
+              </a:ext>
+            </a:extLst>
+          </p:cNvPr>
+          <p:cNvPicPr>
+            <a:picLocks noChangeAspect="1"/>
+          </p:cNvPicPr>
+          <p:nvPr/>
+        </p:nvPicPr>
+        <p:blipFill>
+          <a:blip r:embed="rId9" cstate="print">
+            <a:extLst>
+              <a:ext uri="{28A0092B-C50C-407E-A947-70E740481C1C}">
+                <a14:useLocalDpi xmlns:a14="http://schemas.microsoft.com/office/drawing/2010/main" val="0"/>
+              </a:ext>
+            </a:extLst>
+          </a:blip>
+          <a:srcRect/>
+          <a:stretch/>
+        </p:blipFill>
+        <p:spPr>
+          <a:xfrm flipH="1">
+            <a:off x="3154335" y="9549926"/>
+            <a:ext cx="100846" cy="100846"/>
+          </a:xfrm>
+          <a:prstGeom prst="rect">
+            <a:avLst/>
+          </a:prstGeom>
+        </p:spPr>
+      </p:pic>
+      <p:pic>
+        <p:nvPicPr>
+          <p:cNvPr id="50" name="Picture 49">
+            <a:extLst>
+              <a:ext uri="{FF2B5EF4-FFF2-40B4-BE49-F238E27FC236}">
+                <a16:creationId xmlns:a16="http://schemas.microsoft.com/office/drawing/2014/main" id="{47A2D48D-F11A-E8F9-E4EA-E51A67F63B06}"/>
+              </a:ext>
+            </a:extLst>
+          </p:cNvPr>
+          <p:cNvPicPr>
+            <a:picLocks noChangeAspect="1"/>
+          </p:cNvPicPr>
+          <p:nvPr/>
+        </p:nvPicPr>
+        <p:blipFill>
+          <a:blip r:embed="rId10" cstate="print">
+            <a:extLst>
+              <a:ext uri="{28A0092B-C50C-407E-A947-70E740481C1C}">
+                <a14:useLocalDpi xmlns:a14="http://schemas.microsoft.com/office/drawing/2010/main" val="0"/>
+              </a:ext>
+            </a:extLst>
+          </a:blip>
+          <a:srcRect/>
+          <a:stretch/>
+        </p:blipFill>
+        <p:spPr>
+          <a:xfrm flipH="1">
+            <a:off x="4717881" y="9544698"/>
+            <a:ext cx="100846" cy="100846"/>
           </a:xfrm>
           <a:prstGeom prst="rect">
             <a:avLst/>

</xml_diff>

<commit_message>
SEO optimization, Admin dashboard update, and invoice template improvements
</commit_message>
<xml_diff>
--- a/public/Modern Professional Business invoice Template - Paid.pptx
+++ b/public/Modern Professional Business invoice Template - Paid.pptx
@@ -4390,14 +4390,14 @@
         <p:spPr>
           <a:xfrm>
             <a:off x="836550" y="3671983"/>
-            <a:ext cx="1723444" cy="248419"/>
+            <a:ext cx="2777962" cy="248419"/>
           </a:xfrm>
           <a:prstGeom prst="rect">
             <a:avLst/>
           </a:prstGeom>
         </p:spPr>
         <p:txBody>
-          <a:bodyPr lIns="0" tIns="0" rIns="0" bIns="0" rtlCol="0" anchor="t">
+          <a:bodyPr wrap="square" lIns="0" tIns="0" rIns="0" bIns="0" rtlCol="0" anchor="t">
             <a:spAutoFit/>
           </a:bodyPr>
           <a:lstStyle/>
@@ -4430,15 +4430,15 @@
         </p:nvSpPr>
         <p:spPr>
           <a:xfrm>
-            <a:off x="836550" y="4051300"/>
-            <a:ext cx="1723444" cy="248419"/>
+            <a:off x="836549" y="4051300"/>
+            <a:ext cx="2843327" cy="248419"/>
           </a:xfrm>
           <a:prstGeom prst="rect">
             <a:avLst/>
           </a:prstGeom>
         </p:spPr>
         <p:txBody>
-          <a:bodyPr lIns="0" tIns="0" rIns="0" bIns="0" rtlCol="0" anchor="t">
+          <a:bodyPr wrap="square" lIns="0" tIns="0" rIns="0" bIns="0" rtlCol="0" anchor="t">
             <a:spAutoFit/>
           </a:bodyPr>
           <a:lstStyle/>
@@ -5467,15 +5467,15 @@
         </p:nvSpPr>
         <p:spPr>
           <a:xfrm>
-            <a:off x="832342" y="4443905"/>
-            <a:ext cx="1723444" cy="248419"/>
+            <a:off x="832341" y="4443905"/>
+            <a:ext cx="2869709" cy="248419"/>
           </a:xfrm>
           <a:prstGeom prst="rect">
             <a:avLst/>
           </a:prstGeom>
         </p:spPr>
         <p:txBody>
-          <a:bodyPr lIns="0" tIns="0" rIns="0" bIns="0" rtlCol="0" anchor="t">
+          <a:bodyPr wrap="square" lIns="0" tIns="0" rIns="0" bIns="0" rtlCol="0" anchor="t">
             <a:spAutoFit/>
           </a:bodyPr>
           <a:lstStyle/>
@@ -5514,15 +5514,15 @@
         </p:nvSpPr>
         <p:spPr>
           <a:xfrm>
-            <a:off x="832342" y="4823222"/>
-            <a:ext cx="1723444" cy="248419"/>
+            <a:off x="832341" y="4823222"/>
+            <a:ext cx="2843327" cy="248419"/>
           </a:xfrm>
           <a:prstGeom prst="rect">
             <a:avLst/>
           </a:prstGeom>
         </p:spPr>
         <p:txBody>
-          <a:bodyPr lIns="0" tIns="0" rIns="0" bIns="0" rtlCol="0" anchor="t">
+          <a:bodyPr wrap="square" lIns="0" tIns="0" rIns="0" bIns="0" rtlCol="0" anchor="t">
             <a:spAutoFit/>
           </a:bodyPr>
           <a:lstStyle/>
@@ -5998,14 +5998,14 @@
         <p:spPr>
           <a:xfrm>
             <a:off x="832342" y="5213397"/>
-            <a:ext cx="1723444" cy="248419"/>
+            <a:ext cx="2869708" cy="248419"/>
           </a:xfrm>
           <a:prstGeom prst="rect">
             <a:avLst/>
           </a:prstGeom>
         </p:spPr>
         <p:txBody>
-          <a:bodyPr lIns="0" tIns="0" rIns="0" bIns="0" rtlCol="0" anchor="t">
+          <a:bodyPr wrap="square" lIns="0" tIns="0" rIns="0" bIns="0" rtlCol="0" anchor="t">
             <a:spAutoFit/>
           </a:bodyPr>
           <a:lstStyle/>
@@ -6045,14 +6045,14 @@
         <p:spPr>
           <a:xfrm>
             <a:off x="832342" y="5592714"/>
-            <a:ext cx="1723444" cy="248419"/>
+            <a:ext cx="2869708" cy="248419"/>
           </a:xfrm>
           <a:prstGeom prst="rect">
             <a:avLst/>
           </a:prstGeom>
         </p:spPr>
         <p:txBody>
-          <a:bodyPr lIns="0" tIns="0" rIns="0" bIns="0" rtlCol="0" anchor="t">
+          <a:bodyPr wrap="square" lIns="0" tIns="0" rIns="0" bIns="0" rtlCol="0" anchor="t">
             <a:spAutoFit/>
           </a:bodyPr>
           <a:lstStyle/>

</xml_diff>